<commit_message>
Update project presentation and add algorithm tester
</commit_message>
<xml_diff>
--- a/DSA-3_Project PPT.pptx
+++ b/DSA-3_Project PPT.pptx
@@ -6,17 +6,16 @@
   </p:sldMasterIdLst>
   <p:sldIdLst>
     <p:sldId id="256" r:id="rId2"/>
-    <p:sldId id="257" r:id="rId3"/>
-    <p:sldId id="264" r:id="rId4"/>
-    <p:sldId id="258" r:id="rId5"/>
-    <p:sldId id="261" r:id="rId6"/>
-    <p:sldId id="265" r:id="rId7"/>
-    <p:sldId id="259" r:id="rId8"/>
-    <p:sldId id="267" r:id="rId9"/>
-    <p:sldId id="266" r:id="rId10"/>
-    <p:sldId id="260" r:id="rId11"/>
-    <p:sldId id="262" r:id="rId12"/>
-    <p:sldId id="268" r:id="rId13"/>
+    <p:sldId id="264" r:id="rId3"/>
+    <p:sldId id="258" r:id="rId4"/>
+    <p:sldId id="261" r:id="rId5"/>
+    <p:sldId id="265" r:id="rId6"/>
+    <p:sldId id="259" r:id="rId7"/>
+    <p:sldId id="267" r:id="rId8"/>
+    <p:sldId id="266" r:id="rId9"/>
+    <p:sldId id="260" r:id="rId10"/>
+    <p:sldId id="262" r:id="rId11"/>
+    <p:sldId id="268" r:id="rId12"/>
   </p:sldIdLst>
   <p:sldSz cx="12192000" cy="6858000"/>
   <p:notesSz cx="6858000" cy="9144000"/>
@@ -123,6 +122,42 @@
 </p:presentation>
 </file>
 
+<file path=ppt/changesInfos/changesInfo1.xml><?xml version="1.0" encoding="utf-8"?>
+<pc:chgInfo xmlns:a="http://schemas.openxmlformats.org/drawingml/2006/main" xmlns:r="http://schemas.openxmlformats.org/officeDocument/2006/relationships" xmlns:ac="http://schemas.microsoft.com/office/drawing/2013/main/command" xmlns:pc="http://schemas.microsoft.com/office/powerpoint/2013/main/command">
+  <pc:docChgLst>
+    <pc:chgData name="hansika janumpally" userId="8ad5466844da17bb" providerId="LiveId" clId="{1C93A046-1EEF-4E68-93AA-C0034F8F868A}"/>
+    <pc:docChg chg="delSld modSld">
+      <pc:chgData name="hansika janumpally" userId="8ad5466844da17bb" providerId="LiveId" clId="{1C93A046-1EEF-4E68-93AA-C0034F8F868A}" dt="2026-09-30T03:02:01.340" v="69" actId="47"/>
+      <pc:docMkLst>
+        <pc:docMk/>
+      </pc:docMkLst>
+      <pc:sldChg chg="modSp mod">
+        <pc:chgData name="hansika janumpally" userId="8ad5466844da17bb" providerId="LiveId" clId="{1C93A046-1EEF-4E68-93AA-C0034F8F868A}" dt="2026-09-30T03:01:54.325" v="68" actId="20577"/>
+        <pc:sldMkLst>
+          <pc:docMk/>
+          <pc:sldMk cId="0" sldId="256"/>
+        </pc:sldMkLst>
+        <pc:spChg chg="mod">
+          <ac:chgData name="hansika janumpally" userId="8ad5466844da17bb" providerId="LiveId" clId="{1C93A046-1EEF-4E68-93AA-C0034F8F868A}" dt="2026-09-30T03:01:54.325" v="68" actId="20577"/>
+          <ac:spMkLst>
+            <pc:docMk/>
+            <pc:sldMk cId="0" sldId="256"/>
+            <ac:spMk id="2" creationId="{00000000-0000-0000-0000-000000000000}"/>
+          </ac:spMkLst>
+        </pc:spChg>
+      </pc:sldChg>
+      <pc:sldChg chg="del">
+        <pc:chgData name="hansika janumpally" userId="8ad5466844da17bb" providerId="LiveId" clId="{1C93A046-1EEF-4E68-93AA-C0034F8F868A}" dt="2026-09-30T03:02:01.340" v="69" actId="47"/>
+        <pc:sldMkLst>
+          <pc:docMk/>
+          <pc:sldMk cId="0" sldId="257"/>
+        </pc:sldMkLst>
+      </pc:sldChg>
+    </pc:docChg>
+  </pc:docChgLst>
+</pc:chgInfo>
+</file>
+
 <file path=ppt/slideLayouts/slideLayout1.xml><?xml version="1.0" encoding="utf-8"?>
 <p:sldLayout xmlns:a="http://schemas.openxmlformats.org/drawingml/2006/main" xmlns:r="http://schemas.openxmlformats.org/officeDocument/2006/relationships" xmlns:p="http://schemas.openxmlformats.org/presentationml/2006/main" type="title" preserve="1">
   <p:cSld name="Title Slide">
@@ -266,7 +301,7 @@
           <a:p>
             <a:fld id="{45B1BC09-D557-492E-9C5D-E4CF9E078DE2}" type="datetimeFigureOut">
               <a:rPr lang="en-US" smtClean="0"/>
-              <a:t>9/24/2026</a:t>
+              <a:t>9/30/2026</a:t>
             </a:fld>
             <a:endParaRPr lang="en-US"/>
           </a:p>
@@ -469,7 +504,7 @@
           <a:p>
             <a:fld id="{45B1BC09-D557-492E-9C5D-E4CF9E078DE2}" type="datetimeFigureOut">
               <a:rPr lang="en-US" smtClean="0"/>
-              <a:t>9/24/2026</a:t>
+              <a:t>9/30/2026</a:t>
             </a:fld>
             <a:endParaRPr lang="en-US"/>
           </a:p>
@@ -672,7 +707,7 @@
           <a:p>
             <a:fld id="{45B1BC09-D557-492E-9C5D-E4CF9E078DE2}" type="datetimeFigureOut">
               <a:rPr lang="en-US" smtClean="0"/>
-              <a:t>9/24/2026</a:t>
+              <a:t>9/30/2026</a:t>
             </a:fld>
             <a:endParaRPr lang="en-US"/>
           </a:p>
@@ -875,7 +910,7 @@
           <a:p>
             <a:fld id="{45B1BC09-D557-492E-9C5D-E4CF9E078DE2}" type="datetimeFigureOut">
               <a:rPr lang="en-US" smtClean="0"/>
-              <a:t>9/24/2026</a:t>
+              <a:t>9/30/2026</a:t>
             </a:fld>
             <a:endParaRPr lang="en-US"/>
           </a:p>
@@ -1145,7 +1180,7 @@
           <a:p>
             <a:fld id="{45B1BC09-D557-492E-9C5D-E4CF9E078DE2}" type="datetimeFigureOut">
               <a:rPr lang="en-US" smtClean="0"/>
-              <a:t>9/24/2026</a:t>
+              <a:t>9/30/2026</a:t>
             </a:fld>
             <a:endParaRPr lang="en-US"/>
           </a:p>
@@ -1407,7 +1442,7 @@
           <a:p>
             <a:fld id="{45B1BC09-D557-492E-9C5D-E4CF9E078DE2}" type="datetimeFigureOut">
               <a:rPr lang="en-US" smtClean="0"/>
-              <a:t>9/24/2026</a:t>
+              <a:t>9/30/2026</a:t>
             </a:fld>
             <a:endParaRPr lang="en-US"/>
           </a:p>
@@ -1805,7 +1840,7 @@
           <a:p>
             <a:fld id="{45B1BC09-D557-492E-9C5D-E4CF9E078DE2}" type="datetimeFigureOut">
               <a:rPr lang="en-US" smtClean="0"/>
-              <a:t>9/24/2026</a:t>
+              <a:t>9/30/2026</a:t>
             </a:fld>
             <a:endParaRPr lang="en-US"/>
           </a:p>
@@ -1949,7 +1984,7 @@
           <a:p>
             <a:fld id="{45B1BC09-D557-492E-9C5D-E4CF9E078DE2}" type="datetimeFigureOut">
               <a:rPr lang="en-US" smtClean="0"/>
-              <a:t>9/24/2026</a:t>
+              <a:t>9/30/2026</a:t>
             </a:fld>
             <a:endParaRPr lang="en-US"/>
           </a:p>
@@ -2063,7 +2098,7 @@
           <a:p>
             <a:fld id="{45B1BC09-D557-492E-9C5D-E4CF9E078DE2}" type="datetimeFigureOut">
               <a:rPr lang="en-US" smtClean="0"/>
-              <a:t>9/24/2026</a:t>
+              <a:t>9/30/2026</a:t>
             </a:fld>
             <a:endParaRPr lang="en-US"/>
           </a:p>
@@ -2366,7 +2401,7 @@
           <a:p>
             <a:fld id="{45B1BC09-D557-492E-9C5D-E4CF9E078DE2}" type="datetimeFigureOut">
               <a:rPr lang="en-US" smtClean="0"/>
-              <a:t>9/24/2026</a:t>
+              <a:t>9/30/2026</a:t>
             </a:fld>
             <a:endParaRPr lang="en-US"/>
           </a:p>
@@ -2646,7 +2681,7 @@
           <a:p>
             <a:fld id="{45B1BC09-D557-492E-9C5D-E4CF9E078DE2}" type="datetimeFigureOut">
               <a:rPr lang="en-US" smtClean="0"/>
-              <a:t>9/24/2026</a:t>
+              <a:t>9/30/2026</a:t>
             </a:fld>
             <a:endParaRPr lang="en-US"/>
           </a:p>
@@ -3391,13 +3426,22 @@
               </a:rPr>
             </a:br>
             <a:r>
+              <a:rPr lang="en-US" sz="4000" b="1" dirty="0" err="1">
+                <a:solidFill>
+                  <a:srgbClr val="C00000"/>
+                </a:solidFill>
+                <a:latin typeface="+mn-lt"/>
+              </a:rPr>
+              <a:t>Plagarisim</a:t>
+            </a:r>
+            <a:r>
               <a:rPr lang="en-US" sz="4000" b="1" dirty="0">
                 <a:solidFill>
                   <a:srgbClr val="C00000"/>
                 </a:solidFill>
                 <a:latin typeface="+mn-lt"/>
               </a:rPr>
-              <a:t>Title of the project</a:t>
+              <a:t> Detection in Research Papers</a:t>
             </a:r>
           </a:p>
         </p:txBody>
@@ -3573,7 +3617,7 @@
       </p:grpSpPr>
       <p:sp>
         <p:nvSpPr>
-          <p:cNvPr id="2" name="Rectangle: Rounded Corners 1"/>
+          <p:cNvPr id="3" name="Rectangle: Rounded Corners 2"/>
           <p:cNvSpPr/>
           <p:nvPr/>
         </p:nvSpPr>
@@ -3616,13 +3660,13 @@
       </p:sp>
       <p:sp>
         <p:nvSpPr>
-          <p:cNvPr id="3" name="TextBox 2"/>
+          <p:cNvPr id="4" name="TextBox 3"/>
           <p:cNvSpPr txBox="1"/>
           <p:nvPr/>
         </p:nvSpPr>
         <p:spPr>
           <a:xfrm>
-            <a:off x="2660072" y="187903"/>
+            <a:off x="2660072" y="154134"/>
             <a:ext cx="6871855" cy="584775"/>
           </a:xfrm>
           <a:prstGeom prst="rect">
@@ -3643,7 +3687,7 @@
                   <a:schemeClr val="bg1"/>
                 </a:solidFill>
               </a:rPr>
-              <a:t>Conclusion</a:t>
+              <a:t> Future Scope</a:t>
             </a:r>
           </a:p>
         </p:txBody>
@@ -3653,7 +3697,7 @@
           <p:cNvPr id="5" name="TextBox 4">
             <a:extLst>
               <a:ext uri="{FF2B5EF4-FFF2-40B4-BE49-F238E27FC236}">
-                <a16:creationId xmlns:a16="http://schemas.microsoft.com/office/drawing/2014/main" id="{41F255AE-85F2-273B-E169-DCFDB4BA4D29}"/>
+                <a16:creationId xmlns:a16="http://schemas.microsoft.com/office/drawing/2014/main" id="{82DBC600-EA01-BCBB-A925-7B789C3290F0}"/>
               </a:ext>
             </a:extLst>
           </p:cNvPr>
@@ -3662,8 +3706,8 @@
         </p:nvSpPr>
         <p:spPr>
           <a:xfrm>
-            <a:off x="3048698" y="1282596"/>
-            <a:ext cx="6094602" cy="4619854"/>
+            <a:off x="2922864" y="1425370"/>
+            <a:ext cx="6094602" cy="3788858"/>
           </a:xfrm>
           <a:prstGeom prst="rect">
             <a:avLst/>
@@ -3684,12 +3728,8 @@
               <a:buChar char="•"/>
             </a:pPr>
             <a:r>
-              <a:rPr lang="en-IN" dirty="0" err="1"/>
-              <a:t>PaperCheck</a:t>
-            </a:r>
-            <a:r>
-              <a:rPr lang="en-IN" dirty="0"/>
-              <a:t> provides an automated approach for plagiarism detection. </a:t>
+              <a:rPr lang="en-IN" dirty="0"/>
+              <a:t>Increase the dataset from 100 papers to thousands of papers. </a:t>
             </a:r>
           </a:p>
           <a:p>
@@ -3702,7 +3742,15 @@
             </a:pPr>
             <a:r>
               <a:rPr lang="en-IN" dirty="0"/>
-              <a:t>The system processes research papers and compares their textual content. </a:t>
+              <a:t>Add support for </a:t>
+            </a:r>
+            <a:r>
+              <a:rPr lang="en-IN" b="1" dirty="0"/>
+              <a:t>DOC/DOCX files</a:t>
+            </a:r>
+            <a:r>
+              <a:rPr lang="en-IN" dirty="0"/>
+              <a:t>. </a:t>
             </a:r>
           </a:p>
           <a:p>
@@ -3714,12 +3762,16 @@
               <a:buChar char="•"/>
             </a:pPr>
             <a:r>
+              <a:rPr lang="en-IN" dirty="0"/>
+              <a:t>Add </a:t>
+            </a:r>
+            <a:r>
               <a:rPr lang="en-IN" b="1" dirty="0"/>
-              <a:t>Rolling Hash</a:t>
-            </a:r>
-            <a:r>
-              <a:rPr lang="en-IN" dirty="0"/>
-              <a:t> efficiently generates hash values for K-grams. </a:t>
+              <a:t>OCR</a:t>
+            </a:r>
+            <a:r>
+              <a:rPr lang="en-IN" dirty="0"/>
+              <a:t> for scanned research papers. </a:t>
             </a:r>
           </a:p>
           <a:p>
@@ -3731,12 +3783,8 @@
               <a:buChar char="•"/>
             </a:pPr>
             <a:r>
-              <a:rPr lang="en-IN" b="1" dirty="0"/>
-              <a:t>Rabin-Karp</a:t>
-            </a:r>
-            <a:r>
-              <a:rPr lang="en-IN" dirty="0"/>
-              <a:t> identifies matching sequences using these hash values. </a:t>
+              <a:rPr lang="en-IN" dirty="0"/>
+              <a:t>Highlight the exact matching passages. </a:t>
             </a:r>
           </a:p>
           <a:p>
@@ -3749,7 +3797,7 @@
             </a:pPr>
             <a:r>
               <a:rPr lang="en-IN" dirty="0"/>
-              <a:t>The system generates similarity percentages and ranked matching papers. </a:t>
+              <a:t>Generate downloadable plagiarism reports. </a:t>
             </a:r>
           </a:p>
           <a:p>
@@ -3762,15 +3810,33 @@
             </a:pPr>
             <a:r>
               <a:rPr lang="en-IN" dirty="0"/>
-              <a:t>The project demonstrates how </a:t>
-            </a:r>
-            <a:r>
-              <a:rPr lang="en-IN" b="1" dirty="0"/>
-              <a:t>DSA concepts can be applied to a real-world problem</a:t>
-            </a:r>
-            <a:r>
-              <a:rPr lang="en-IN" dirty="0"/>
-              <a:t>.</a:t>
+              <a:t>Add multiple similarity detection techniques. </a:t>
+            </a:r>
+          </a:p>
+          <a:p>
+            <a:pPr marL="342900" lvl="0" indent="-342900">
+              <a:lnSpc>
+                <a:spcPct val="150000"/>
+              </a:lnSpc>
+              <a:buFont typeface="Arial" panose="020B0604020202020204" pitchFamily="34" charset="0"/>
+              <a:buChar char="•"/>
+            </a:pPr>
+            <a:r>
+              <a:rPr lang="en-IN" dirty="0"/>
+              <a:t>Improve processing speed for large datasets. </a:t>
+            </a:r>
+          </a:p>
+          <a:p>
+            <a:pPr marL="342900" lvl="0" indent="-342900">
+              <a:lnSpc>
+                <a:spcPct val="150000"/>
+              </a:lnSpc>
+              <a:buFont typeface="Arial" panose="020B0604020202020204" pitchFamily="34" charset="0"/>
+              <a:buChar char="•"/>
+            </a:pPr>
+            <a:r>
+              <a:rPr lang="en-IN" dirty="0"/>
+              <a:t>Add a web-based cloud deployment.</a:t>
             </a:r>
           </a:p>
         </p:txBody>
@@ -3784,257 +3850,6 @@
 </file>
 
 <file path=ppt/slides/slide11.xml><?xml version="1.0" encoding="utf-8"?>
-<p:sld xmlns:a="http://schemas.openxmlformats.org/drawingml/2006/main" xmlns:r="http://schemas.openxmlformats.org/officeDocument/2006/relationships" xmlns:p="http://schemas.openxmlformats.org/presentationml/2006/main">
-  <p:cSld>
-    <p:spTree>
-      <p:nvGrpSpPr>
-        <p:cNvPr id="1" name=""/>
-        <p:cNvGrpSpPr/>
-        <p:nvPr/>
-      </p:nvGrpSpPr>
-      <p:grpSpPr>
-        <a:xfrm>
-          <a:off x="0" y="0"/>
-          <a:ext cx="0" cy="0"/>
-          <a:chOff x="0" y="0"/>
-          <a:chExt cx="0" cy="0"/>
-        </a:xfrm>
-      </p:grpSpPr>
-      <p:sp>
-        <p:nvSpPr>
-          <p:cNvPr id="3" name="Rectangle: Rounded Corners 2"/>
-          <p:cNvSpPr/>
-          <p:nvPr/>
-        </p:nvSpPr>
-        <p:spPr>
-          <a:xfrm>
-            <a:off x="3736109" y="221673"/>
-            <a:ext cx="4719782" cy="517236"/>
-          </a:xfrm>
-          <a:prstGeom prst="roundRect">
-            <a:avLst/>
-          </a:prstGeom>
-          <a:solidFill>
-            <a:srgbClr val="C00000"/>
-          </a:solidFill>
-        </p:spPr>
-        <p:style>
-          <a:lnRef idx="2">
-            <a:schemeClr val="accent1">
-              <a:shade val="15000"/>
-            </a:schemeClr>
-          </a:lnRef>
-          <a:fillRef idx="1">
-            <a:schemeClr val="accent1"/>
-          </a:fillRef>
-          <a:effectRef idx="0">
-            <a:schemeClr val="accent1"/>
-          </a:effectRef>
-          <a:fontRef idx="minor">
-            <a:schemeClr val="lt1"/>
-          </a:fontRef>
-        </p:style>
-        <p:txBody>
-          <a:bodyPr rtlCol="0" anchor="ctr"/>
-          <a:lstStyle/>
-          <a:p>
-            <a:pPr algn="ctr"/>
-            <a:endParaRPr lang="en-US"/>
-          </a:p>
-        </p:txBody>
-      </p:sp>
-      <p:sp>
-        <p:nvSpPr>
-          <p:cNvPr id="4" name="TextBox 3"/>
-          <p:cNvSpPr txBox="1"/>
-          <p:nvPr/>
-        </p:nvSpPr>
-        <p:spPr>
-          <a:xfrm>
-            <a:off x="2660072" y="154134"/>
-            <a:ext cx="6871855" cy="584775"/>
-          </a:xfrm>
-          <a:prstGeom prst="rect">
-            <a:avLst/>
-          </a:prstGeom>
-          <a:noFill/>
-        </p:spPr>
-        <p:txBody>
-          <a:bodyPr wrap="square" rtlCol="0">
-            <a:spAutoFit/>
-          </a:bodyPr>
-          <a:lstStyle/>
-          <a:p>
-            <a:pPr algn="ctr"/>
-            <a:r>
-              <a:rPr lang="en-US" sz="3200" b="1" dirty="0">
-                <a:solidFill>
-                  <a:schemeClr val="bg1"/>
-                </a:solidFill>
-              </a:rPr>
-              <a:t> Future Scope</a:t>
-            </a:r>
-          </a:p>
-        </p:txBody>
-      </p:sp>
-      <p:sp>
-        <p:nvSpPr>
-          <p:cNvPr id="5" name="TextBox 4">
-            <a:extLst>
-              <a:ext uri="{FF2B5EF4-FFF2-40B4-BE49-F238E27FC236}">
-                <a16:creationId xmlns:a16="http://schemas.microsoft.com/office/drawing/2014/main" id="{82DBC600-EA01-BCBB-A925-7B789C3290F0}"/>
-              </a:ext>
-            </a:extLst>
-          </p:cNvPr>
-          <p:cNvSpPr txBox="1"/>
-          <p:nvPr/>
-        </p:nvSpPr>
-        <p:spPr>
-          <a:xfrm>
-            <a:off x="2922864" y="1425370"/>
-            <a:ext cx="6094602" cy="3788858"/>
-          </a:xfrm>
-          <a:prstGeom prst="rect">
-            <a:avLst/>
-          </a:prstGeom>
-          <a:noFill/>
-        </p:spPr>
-        <p:txBody>
-          <a:bodyPr wrap="square">
-            <a:spAutoFit/>
-          </a:bodyPr>
-          <a:lstStyle/>
-          <a:p>
-            <a:pPr marL="342900" lvl="0" indent="-342900">
-              <a:lnSpc>
-                <a:spcPct val="150000"/>
-              </a:lnSpc>
-              <a:buFont typeface="Arial" panose="020B0604020202020204" pitchFamily="34" charset="0"/>
-              <a:buChar char="•"/>
-            </a:pPr>
-            <a:r>
-              <a:rPr lang="en-IN" dirty="0"/>
-              <a:t>Increase the dataset from 100 papers to thousands of papers. </a:t>
-            </a:r>
-          </a:p>
-          <a:p>
-            <a:pPr marL="342900" lvl="0" indent="-342900">
-              <a:lnSpc>
-                <a:spcPct val="150000"/>
-              </a:lnSpc>
-              <a:buFont typeface="Arial" panose="020B0604020202020204" pitchFamily="34" charset="0"/>
-              <a:buChar char="•"/>
-            </a:pPr>
-            <a:r>
-              <a:rPr lang="en-IN" dirty="0"/>
-              <a:t>Add support for </a:t>
-            </a:r>
-            <a:r>
-              <a:rPr lang="en-IN" b="1" dirty="0"/>
-              <a:t>DOC/DOCX files</a:t>
-            </a:r>
-            <a:r>
-              <a:rPr lang="en-IN" dirty="0"/>
-              <a:t>. </a:t>
-            </a:r>
-          </a:p>
-          <a:p>
-            <a:pPr marL="342900" lvl="0" indent="-342900">
-              <a:lnSpc>
-                <a:spcPct val="150000"/>
-              </a:lnSpc>
-              <a:buFont typeface="Arial" panose="020B0604020202020204" pitchFamily="34" charset="0"/>
-              <a:buChar char="•"/>
-            </a:pPr>
-            <a:r>
-              <a:rPr lang="en-IN" dirty="0"/>
-              <a:t>Add </a:t>
-            </a:r>
-            <a:r>
-              <a:rPr lang="en-IN" b="1" dirty="0"/>
-              <a:t>OCR</a:t>
-            </a:r>
-            <a:r>
-              <a:rPr lang="en-IN" dirty="0"/>
-              <a:t> for scanned research papers. </a:t>
-            </a:r>
-          </a:p>
-          <a:p>
-            <a:pPr marL="342900" lvl="0" indent="-342900">
-              <a:lnSpc>
-                <a:spcPct val="150000"/>
-              </a:lnSpc>
-              <a:buFont typeface="Arial" panose="020B0604020202020204" pitchFamily="34" charset="0"/>
-              <a:buChar char="•"/>
-            </a:pPr>
-            <a:r>
-              <a:rPr lang="en-IN" dirty="0"/>
-              <a:t>Highlight the exact matching passages. </a:t>
-            </a:r>
-          </a:p>
-          <a:p>
-            <a:pPr marL="342900" lvl="0" indent="-342900">
-              <a:lnSpc>
-                <a:spcPct val="150000"/>
-              </a:lnSpc>
-              <a:buFont typeface="Arial" panose="020B0604020202020204" pitchFamily="34" charset="0"/>
-              <a:buChar char="•"/>
-            </a:pPr>
-            <a:r>
-              <a:rPr lang="en-IN" dirty="0"/>
-              <a:t>Generate downloadable plagiarism reports. </a:t>
-            </a:r>
-          </a:p>
-          <a:p>
-            <a:pPr marL="342900" lvl="0" indent="-342900">
-              <a:lnSpc>
-                <a:spcPct val="150000"/>
-              </a:lnSpc>
-              <a:buFont typeface="Arial" panose="020B0604020202020204" pitchFamily="34" charset="0"/>
-              <a:buChar char="•"/>
-            </a:pPr>
-            <a:r>
-              <a:rPr lang="en-IN" dirty="0"/>
-              <a:t>Add multiple similarity detection techniques. </a:t>
-            </a:r>
-          </a:p>
-          <a:p>
-            <a:pPr marL="342900" lvl="0" indent="-342900">
-              <a:lnSpc>
-                <a:spcPct val="150000"/>
-              </a:lnSpc>
-              <a:buFont typeface="Arial" panose="020B0604020202020204" pitchFamily="34" charset="0"/>
-              <a:buChar char="•"/>
-            </a:pPr>
-            <a:r>
-              <a:rPr lang="en-IN" dirty="0"/>
-              <a:t>Improve processing speed for large datasets. </a:t>
-            </a:r>
-          </a:p>
-          <a:p>
-            <a:pPr marL="342900" lvl="0" indent="-342900">
-              <a:lnSpc>
-                <a:spcPct val="150000"/>
-              </a:lnSpc>
-              <a:buFont typeface="Arial" panose="020B0604020202020204" pitchFamily="34" charset="0"/>
-              <a:buChar char="•"/>
-            </a:pPr>
-            <a:r>
-              <a:rPr lang="en-IN" dirty="0"/>
-              <a:t>Add a web-based cloud deployment.</a:t>
-            </a:r>
-          </a:p>
-        </p:txBody>
-      </p:sp>
-    </p:spTree>
-  </p:cSld>
-  <p:clrMapOvr>
-    <a:masterClrMapping/>
-  </p:clrMapOvr>
-</p:sld>
-</file>
-
-<file path=ppt/slides/slide12.xml><?xml version="1.0" encoding="utf-8"?>
 <p:sld xmlns:a="http://schemas.openxmlformats.org/drawingml/2006/main" xmlns:r="http://schemas.openxmlformats.org/officeDocument/2006/relationships" xmlns:p="http://schemas.openxmlformats.org/presentationml/2006/main">
   <p:cSld>
     <p:spTree>
@@ -4129,281 +3944,7 @@
       </p:grpSpPr>
       <p:sp>
         <p:nvSpPr>
-          <p:cNvPr id="7" name="TextBox 6">
-            <a:extLst>
-              <a:ext uri="{FF2B5EF4-FFF2-40B4-BE49-F238E27FC236}">
-                <a16:creationId xmlns:a16="http://schemas.microsoft.com/office/drawing/2014/main" id="{1C70C049-38C4-198F-3181-AACE07DE24AE}"/>
-              </a:ext>
-            </a:extLst>
-          </p:cNvPr>
-          <p:cNvSpPr txBox="1"/>
-          <p:nvPr/>
-        </p:nvSpPr>
-        <p:spPr>
-          <a:xfrm>
-            <a:off x="3736109" y="806448"/>
-            <a:ext cx="6936386" cy="5835572"/>
-          </a:xfrm>
-          <a:prstGeom prst="rect">
-            <a:avLst/>
-          </a:prstGeom>
-          <a:noFill/>
-        </p:spPr>
-        <p:txBody>
-          <a:bodyPr wrap="none" rtlCol="0">
-            <a:spAutoFit/>
-          </a:bodyPr>
-          <a:lstStyle/>
-          <a:p>
-            <a:pPr marL="457200" indent="-457200" algn="l" rtl="0" eaLnBrk="1" fontAlgn="t" latinLnBrk="0" hangingPunct="1">
-              <a:lnSpc>
-                <a:spcPct val="150000"/>
-              </a:lnSpc>
-              <a:spcBef>
-                <a:spcPts val="0"/>
-              </a:spcBef>
-              <a:spcAft>
-                <a:spcPts val="0"/>
-              </a:spcAft>
-              <a:buFont typeface="Arial" panose="020B0604020202020204" pitchFamily="34" charset="0"/>
-              <a:buChar char="•"/>
-            </a:pPr>
-            <a:r>
-              <a:rPr lang="en-US" sz="3200" b="0" i="0" u="none" strike="noStrike" kern="1200" dirty="0">
-                <a:solidFill>
-                  <a:srgbClr val="000000"/>
-                </a:solidFill>
-                <a:effectLst/>
-                <a:latin typeface="Calibri" panose="020F0502020204030204" pitchFamily="34" charset="0"/>
-              </a:rPr>
-              <a:t>Abstract</a:t>
-            </a:r>
-          </a:p>
-          <a:p>
-            <a:pPr marL="457200" indent="-457200" algn="l" rtl="0" eaLnBrk="1" fontAlgn="t" latinLnBrk="0" hangingPunct="1">
-              <a:lnSpc>
-                <a:spcPct val="150000"/>
-              </a:lnSpc>
-              <a:spcBef>
-                <a:spcPts val="0"/>
-              </a:spcBef>
-              <a:spcAft>
-                <a:spcPts val="0"/>
-              </a:spcAft>
-              <a:buFont typeface="Arial" panose="020B0604020202020204" pitchFamily="34" charset="0"/>
-              <a:buChar char="•"/>
-            </a:pPr>
-            <a:r>
-              <a:rPr lang="en-US" sz="3200" b="0" i="0" u="none" strike="noStrike" kern="1200" dirty="0">
-                <a:solidFill>
-                  <a:srgbClr val="000000"/>
-                </a:solidFill>
-                <a:effectLst/>
-                <a:latin typeface="Calibri" panose="020F0502020204030204" pitchFamily="34" charset="0"/>
-              </a:rPr>
-              <a:t>Introduction</a:t>
-            </a:r>
-            <a:endParaRPr lang="en-IN" sz="3200" b="0" i="0" u="none" strike="noStrike" dirty="0">
-              <a:effectLst/>
-              <a:latin typeface="Arial" panose="020B0604020202020204" pitchFamily="34" charset="0"/>
-            </a:endParaRPr>
-          </a:p>
-          <a:p>
-            <a:pPr marL="457200" indent="-457200" algn="l" rtl="0" eaLnBrk="1" fontAlgn="t" latinLnBrk="0" hangingPunct="1">
-              <a:lnSpc>
-                <a:spcPct val="150000"/>
-              </a:lnSpc>
-              <a:spcBef>
-                <a:spcPts val="0"/>
-              </a:spcBef>
-              <a:spcAft>
-                <a:spcPts val="800"/>
-              </a:spcAft>
-              <a:buFont typeface="Arial" panose="020B0604020202020204" pitchFamily="34" charset="0"/>
-              <a:buChar char="•"/>
-            </a:pPr>
-            <a:r>
-              <a:rPr lang="en-US" sz="3200" b="0" i="0" u="none" strike="noStrike" dirty="0">
-                <a:solidFill>
-                  <a:srgbClr val="000000"/>
-                </a:solidFill>
-                <a:effectLst/>
-                <a:latin typeface="Calibri" panose="020F0502020204030204" pitchFamily="34" charset="0"/>
-                <a:ea typeface="Times New Roman" panose="02020603050405020304" pitchFamily="18" charset="0"/>
-                <a:cs typeface="Gautami" panose="020B0502040204020203" pitchFamily="34" charset="0"/>
-              </a:rPr>
-              <a:t>Literature survey</a:t>
-            </a:r>
-            <a:endParaRPr lang="en-IN" sz="3200" b="0" i="0" u="none" strike="noStrike" dirty="0">
-              <a:effectLst/>
-              <a:latin typeface="Arial" panose="020B0604020202020204" pitchFamily="34" charset="0"/>
-            </a:endParaRPr>
-          </a:p>
-          <a:p>
-            <a:pPr marL="457200" indent="-457200" algn="l" rtl="0" eaLnBrk="1" fontAlgn="t" latinLnBrk="0" hangingPunct="1">
-              <a:lnSpc>
-                <a:spcPct val="107000"/>
-              </a:lnSpc>
-              <a:spcBef>
-                <a:spcPts val="0"/>
-              </a:spcBef>
-              <a:spcAft>
-                <a:spcPts val="800"/>
-              </a:spcAft>
-              <a:buFont typeface="Arial" panose="020B0604020202020204" pitchFamily="34" charset="0"/>
-              <a:buChar char="•"/>
-            </a:pPr>
-            <a:r>
-              <a:rPr lang="en-US" sz="3200" b="0" i="0" u="none" strike="noStrike" dirty="0">
-                <a:solidFill>
-                  <a:srgbClr val="000000"/>
-                </a:solidFill>
-                <a:effectLst/>
-                <a:latin typeface="Calibri" panose="020F0502020204030204" pitchFamily="34" charset="0"/>
-                <a:ea typeface="Times New Roman" panose="02020603050405020304" pitchFamily="18" charset="0"/>
-                <a:cs typeface="Gautami" panose="020B0502040204020203" pitchFamily="34" charset="0"/>
-              </a:rPr>
-              <a:t>Problem Statement and Objectives</a:t>
-            </a:r>
-            <a:endParaRPr lang="en-IN" sz="3200" b="0" i="0" u="none" strike="noStrike" dirty="0">
-              <a:effectLst/>
-              <a:latin typeface="Arial" panose="020B0604020202020204" pitchFamily="34" charset="0"/>
-            </a:endParaRPr>
-          </a:p>
-          <a:p>
-            <a:pPr marL="457200" indent="-457200" algn="l" rtl="0" eaLnBrk="1" fontAlgn="t" latinLnBrk="0" hangingPunct="1">
-              <a:lnSpc>
-                <a:spcPct val="107000"/>
-              </a:lnSpc>
-              <a:spcBef>
-                <a:spcPts val="0"/>
-              </a:spcBef>
-              <a:spcAft>
-                <a:spcPts val="800"/>
-              </a:spcAft>
-              <a:buFont typeface="Arial" panose="020B0604020202020204" pitchFamily="34" charset="0"/>
-              <a:buChar char="•"/>
-            </a:pPr>
-            <a:r>
-              <a:rPr lang="en-US" sz="3200" b="0" i="0" u="none" strike="noStrike" dirty="0">
-                <a:solidFill>
-                  <a:srgbClr val="000000"/>
-                </a:solidFill>
-                <a:effectLst/>
-                <a:latin typeface="Calibri" panose="020F0502020204030204" pitchFamily="34" charset="0"/>
-                <a:ea typeface="Times New Roman" panose="02020603050405020304" pitchFamily="18" charset="0"/>
-                <a:cs typeface="Gautami" panose="020B0502040204020203" pitchFamily="34" charset="0"/>
-              </a:rPr>
-              <a:t>Hardware and Software requirements</a:t>
-            </a:r>
-            <a:endParaRPr lang="en-IN" sz="3200" b="0" i="0" u="none" strike="noStrike" dirty="0">
-              <a:effectLst/>
-              <a:latin typeface="Arial" panose="020B0604020202020204" pitchFamily="34" charset="0"/>
-            </a:endParaRPr>
-          </a:p>
-          <a:p>
-            <a:pPr marL="457200" indent="-457200" algn="l" rtl="0" eaLnBrk="1" fontAlgn="t" latinLnBrk="0" hangingPunct="1">
-              <a:lnSpc>
-                <a:spcPct val="107000"/>
-              </a:lnSpc>
-              <a:spcBef>
-                <a:spcPts val="0"/>
-              </a:spcBef>
-              <a:spcAft>
-                <a:spcPts val="800"/>
-              </a:spcAft>
-              <a:buFont typeface="Arial" panose="020B0604020202020204" pitchFamily="34" charset="0"/>
-              <a:buChar char="•"/>
-            </a:pPr>
-            <a:r>
-              <a:rPr lang="en-US" sz="3200" b="0" i="0" u="none" strike="noStrike" dirty="0">
-                <a:solidFill>
-                  <a:srgbClr val="000000"/>
-                </a:solidFill>
-                <a:effectLst/>
-                <a:latin typeface="Calibri" panose="020F0502020204030204" pitchFamily="34" charset="0"/>
-                <a:ea typeface="Times New Roman" panose="02020603050405020304" pitchFamily="18" charset="0"/>
-                <a:cs typeface="Gautami" panose="020B0502040204020203" pitchFamily="34" charset="0"/>
-              </a:rPr>
-              <a:t>Results</a:t>
-            </a:r>
-            <a:endParaRPr lang="en-IN" sz="3200" b="0" i="0" u="none" strike="noStrike" dirty="0">
-              <a:effectLst/>
-              <a:latin typeface="Arial" panose="020B0604020202020204" pitchFamily="34" charset="0"/>
-            </a:endParaRPr>
-          </a:p>
-          <a:p>
-            <a:pPr marL="457200" indent="-457200" algn="l" rtl="0" eaLnBrk="1" fontAlgn="t" latinLnBrk="0" hangingPunct="1">
-              <a:lnSpc>
-                <a:spcPct val="107000"/>
-              </a:lnSpc>
-              <a:spcBef>
-                <a:spcPts val="0"/>
-              </a:spcBef>
-              <a:spcAft>
-                <a:spcPts val="800"/>
-              </a:spcAft>
-              <a:buFont typeface="Arial" panose="020B0604020202020204" pitchFamily="34" charset="0"/>
-              <a:buChar char="•"/>
-            </a:pPr>
-            <a:r>
-              <a:rPr lang="en-US" sz="3200" b="0" i="0" u="none" strike="noStrike" dirty="0">
-                <a:solidFill>
-                  <a:srgbClr val="000000"/>
-                </a:solidFill>
-                <a:effectLst/>
-                <a:latin typeface="Calibri" panose="020F0502020204030204" pitchFamily="34" charset="0"/>
-                <a:ea typeface="Times New Roman" panose="02020603050405020304" pitchFamily="18" charset="0"/>
-                <a:cs typeface="Gautami" panose="020B0502040204020203" pitchFamily="34" charset="0"/>
-              </a:rPr>
-              <a:t>Conclusion </a:t>
-            </a:r>
-          </a:p>
-          <a:p>
-            <a:pPr marL="457200" indent="-457200" algn="l" rtl="0" eaLnBrk="1" fontAlgn="t" latinLnBrk="0" hangingPunct="1">
-              <a:lnSpc>
-                <a:spcPct val="107000"/>
-              </a:lnSpc>
-              <a:spcBef>
-                <a:spcPts val="0"/>
-              </a:spcBef>
-              <a:spcAft>
-                <a:spcPts val="800"/>
-              </a:spcAft>
-              <a:buFont typeface="Arial" panose="020B0604020202020204" pitchFamily="34" charset="0"/>
-              <a:buChar char="•"/>
-            </a:pPr>
-            <a:r>
-              <a:rPr lang="en-US" sz="3200" b="0" i="0" u="none" strike="noStrike" dirty="0">
-                <a:solidFill>
-                  <a:srgbClr val="000000"/>
-                </a:solidFill>
-                <a:effectLst/>
-                <a:latin typeface="Calibri" panose="020F0502020204030204" pitchFamily="34" charset="0"/>
-                <a:ea typeface="Times New Roman" panose="02020603050405020304" pitchFamily="18" charset="0"/>
-                <a:cs typeface="Gautami" panose="020B0502040204020203" pitchFamily="34" charset="0"/>
-              </a:rPr>
-              <a:t>Future Scope </a:t>
-            </a:r>
-            <a:endParaRPr lang="en-IN" sz="3200" b="0" i="0" u="none" strike="noStrike" dirty="0">
-              <a:effectLst/>
-              <a:latin typeface="Arial" panose="020B0604020202020204" pitchFamily="34" charset="0"/>
-            </a:endParaRPr>
-          </a:p>
-          <a:p>
-            <a:endParaRPr lang="en-IN" dirty="0"/>
-          </a:p>
-        </p:txBody>
-      </p:sp>
-      <p:sp>
-        <p:nvSpPr>
-          <p:cNvPr id="8" name="Rectangle: Rounded Corners 7">
-            <a:extLst>
-              <a:ext uri="{FF2B5EF4-FFF2-40B4-BE49-F238E27FC236}">
-                <a16:creationId xmlns:a16="http://schemas.microsoft.com/office/drawing/2014/main" id="{3EAC2F32-24D5-FDE9-EB0F-31C7733C95E6}"/>
-              </a:ext>
-            </a:extLst>
-          </p:cNvPr>
+          <p:cNvPr id="3" name="Rectangle: Rounded Corners 2"/>
           <p:cNvSpPr/>
           <p:nvPr/>
         </p:nvSpPr>
@@ -4446,10 +3987,44 @@
       </p:sp>
       <p:sp>
         <p:nvSpPr>
-          <p:cNvPr id="9" name="TextBox 8">
+          <p:cNvPr id="2" name="TextBox 1"/>
+          <p:cNvSpPr txBox="1"/>
+          <p:nvPr/>
+        </p:nvSpPr>
+        <p:spPr>
+          <a:xfrm>
+            <a:off x="2660072" y="221673"/>
+            <a:ext cx="6871855" cy="584775"/>
+          </a:xfrm>
+          <a:prstGeom prst="rect">
+            <a:avLst/>
+          </a:prstGeom>
+          <a:noFill/>
+        </p:spPr>
+        <p:txBody>
+          <a:bodyPr wrap="square" rtlCol="0">
+            <a:spAutoFit/>
+          </a:bodyPr>
+          <a:lstStyle/>
+          <a:p>
+            <a:pPr algn="ctr"/>
+            <a:r>
+              <a:rPr lang="en-US" sz="3200" b="1" dirty="0">
+                <a:solidFill>
+                  <a:schemeClr val="bg1"/>
+                </a:solidFill>
+              </a:rPr>
+              <a:t>Abstract</a:t>
+            </a:r>
+          </a:p>
+        </p:txBody>
+      </p:sp>
+      <p:sp>
+        <p:nvSpPr>
+          <p:cNvPr id="5" name="TextBox 4">
             <a:extLst>
               <a:ext uri="{FF2B5EF4-FFF2-40B4-BE49-F238E27FC236}">
-                <a16:creationId xmlns:a16="http://schemas.microsoft.com/office/drawing/2014/main" id="{CCA499C0-FC38-6642-1E16-B8CFFC9C9314}"/>
+                <a16:creationId xmlns:a16="http://schemas.microsoft.com/office/drawing/2014/main" id="{50936085-17BE-F8DE-346C-7B5ECBACC680}"/>
               </a:ext>
             </a:extLst>
           </p:cNvPr>
@@ -4458,8 +4033,8 @@
         </p:nvSpPr>
         <p:spPr>
           <a:xfrm>
-            <a:off x="2660072" y="221673"/>
-            <a:ext cx="6871855" cy="584775"/>
+            <a:off x="2854353" y="1742320"/>
+            <a:ext cx="8386893" cy="3373359"/>
           </a:xfrm>
           <a:prstGeom prst="rect">
             <a:avLst/>
@@ -4467,24 +4042,34 @@
           <a:noFill/>
         </p:spPr>
         <p:txBody>
-          <a:bodyPr wrap="square" rtlCol="0">
+          <a:bodyPr wrap="square">
             <a:spAutoFit/>
           </a:bodyPr>
           <a:lstStyle/>
           <a:p>
-            <a:pPr algn="ctr"/>
-            <a:r>
-              <a:rPr lang="en-US" sz="3200" b="1" dirty="0">
-                <a:solidFill>
-                  <a:schemeClr val="bg1"/>
-                </a:solidFill>
-              </a:rPr>
-              <a:t>Contents</a:t>
+            <a:pPr algn="just">
+              <a:lnSpc>
+                <a:spcPct val="150000"/>
+              </a:lnSpc>
+              <a:buNone/>
+            </a:pPr>
+            <a:r>
+              <a:rPr lang="en-IN" dirty="0" err="1"/>
+              <a:t>PaperCheck</a:t>
+            </a:r>
+            <a:r>
+              <a:rPr lang="en-IN" dirty="0"/>
+              <a:t> is a plagiarism detection system designed to identify similarities between an uploaded research paper and a dataset of reference research papers. The system extracts text from the uploaded PDF, preprocesses the content, and divides it into K-grams. Rolling Hash is used to generate hash values for these text sequences, while the Rabin-Karp algorithm efficiently compares the hash values to identify matching content. The system calculates the similarity percentage and provides a ranked list of matching reference papers. This project demonstrates the practical application of Data Structures and Algorithms to solve the problem of efficient plagiarism detection.</a:t>
             </a:r>
           </a:p>
         </p:txBody>
       </p:sp>
     </p:spTree>
+    <p:extLst>
+      <p:ext uri="{BB962C8B-B14F-4D97-AF65-F5344CB8AC3E}">
+        <p14:creationId xmlns:p14="http://schemas.microsoft.com/office/powerpoint/2010/main" val="1672422596"/>
+      </p:ext>
+    </p:extLst>
   </p:cSld>
   <p:clrMapOvr>
     <a:masterClrMapping/>
@@ -4511,7 +4096,7 @@
       </p:grpSpPr>
       <p:sp>
         <p:nvSpPr>
-          <p:cNvPr id="3" name="Rectangle: Rounded Corners 2"/>
+          <p:cNvPr id="2" name="Rectangle: Rounded Corners 1"/>
           <p:cNvSpPr/>
           <p:nvPr/>
         </p:nvSpPr>
@@ -4554,158 +4139,6 @@
       </p:sp>
       <p:sp>
         <p:nvSpPr>
-          <p:cNvPr id="2" name="TextBox 1"/>
-          <p:cNvSpPr txBox="1"/>
-          <p:nvPr/>
-        </p:nvSpPr>
-        <p:spPr>
-          <a:xfrm>
-            <a:off x="2660072" y="221673"/>
-            <a:ext cx="6871855" cy="584775"/>
-          </a:xfrm>
-          <a:prstGeom prst="rect">
-            <a:avLst/>
-          </a:prstGeom>
-          <a:noFill/>
-        </p:spPr>
-        <p:txBody>
-          <a:bodyPr wrap="square" rtlCol="0">
-            <a:spAutoFit/>
-          </a:bodyPr>
-          <a:lstStyle/>
-          <a:p>
-            <a:pPr algn="ctr"/>
-            <a:r>
-              <a:rPr lang="en-US" sz="3200" b="1" dirty="0">
-                <a:solidFill>
-                  <a:schemeClr val="bg1"/>
-                </a:solidFill>
-              </a:rPr>
-              <a:t>Abstract</a:t>
-            </a:r>
-          </a:p>
-        </p:txBody>
-      </p:sp>
-      <p:sp>
-        <p:nvSpPr>
-          <p:cNvPr id="5" name="TextBox 4">
-            <a:extLst>
-              <a:ext uri="{FF2B5EF4-FFF2-40B4-BE49-F238E27FC236}">
-                <a16:creationId xmlns:a16="http://schemas.microsoft.com/office/drawing/2014/main" id="{50936085-17BE-F8DE-346C-7B5ECBACC680}"/>
-              </a:ext>
-            </a:extLst>
-          </p:cNvPr>
-          <p:cNvSpPr txBox="1"/>
-          <p:nvPr/>
-        </p:nvSpPr>
-        <p:spPr>
-          <a:xfrm>
-            <a:off x="2854353" y="1742320"/>
-            <a:ext cx="8386893" cy="3373359"/>
-          </a:xfrm>
-          <a:prstGeom prst="rect">
-            <a:avLst/>
-          </a:prstGeom>
-          <a:noFill/>
-        </p:spPr>
-        <p:txBody>
-          <a:bodyPr wrap="square">
-            <a:spAutoFit/>
-          </a:bodyPr>
-          <a:lstStyle/>
-          <a:p>
-            <a:pPr algn="just">
-              <a:lnSpc>
-                <a:spcPct val="150000"/>
-              </a:lnSpc>
-              <a:buNone/>
-            </a:pPr>
-            <a:r>
-              <a:rPr lang="en-IN" dirty="0" err="1"/>
-              <a:t>PaperCheck</a:t>
-            </a:r>
-            <a:r>
-              <a:rPr lang="en-IN" dirty="0"/>
-              <a:t> is a plagiarism detection system designed to identify similarities between an uploaded research paper and a dataset of reference research papers. The system extracts text from the uploaded PDF, preprocesses the content, and divides it into K-grams. Rolling Hash is used to generate hash values for these text sequences, while the Rabin-Karp algorithm efficiently compares the hash values to identify matching content. The system calculates the similarity percentage and provides a ranked list of matching reference papers. This project demonstrates the practical application of Data Structures and Algorithms to solve the problem of efficient plagiarism detection.</a:t>
-            </a:r>
-          </a:p>
-        </p:txBody>
-      </p:sp>
-    </p:spTree>
-    <p:extLst>
-      <p:ext uri="{BB962C8B-B14F-4D97-AF65-F5344CB8AC3E}">
-        <p14:creationId xmlns:p14="http://schemas.microsoft.com/office/powerpoint/2010/main" val="1672422596"/>
-      </p:ext>
-    </p:extLst>
-  </p:cSld>
-  <p:clrMapOvr>
-    <a:masterClrMapping/>
-  </p:clrMapOvr>
-</p:sld>
-</file>
-
-<file path=ppt/slides/slide4.xml><?xml version="1.0" encoding="utf-8"?>
-<p:sld xmlns:a="http://schemas.openxmlformats.org/drawingml/2006/main" xmlns:r="http://schemas.openxmlformats.org/officeDocument/2006/relationships" xmlns:p="http://schemas.openxmlformats.org/presentationml/2006/main">
-  <p:cSld>
-    <p:spTree>
-      <p:nvGrpSpPr>
-        <p:cNvPr id="1" name=""/>
-        <p:cNvGrpSpPr/>
-        <p:nvPr/>
-      </p:nvGrpSpPr>
-      <p:grpSpPr>
-        <a:xfrm>
-          <a:off x="0" y="0"/>
-          <a:ext cx="0" cy="0"/>
-          <a:chOff x="0" y="0"/>
-          <a:chExt cx="0" cy="0"/>
-        </a:xfrm>
-      </p:grpSpPr>
-      <p:sp>
-        <p:nvSpPr>
-          <p:cNvPr id="2" name="Rectangle: Rounded Corners 1"/>
-          <p:cNvSpPr/>
-          <p:nvPr/>
-        </p:nvSpPr>
-        <p:spPr>
-          <a:xfrm>
-            <a:off x="3736109" y="221673"/>
-            <a:ext cx="4719782" cy="517236"/>
-          </a:xfrm>
-          <a:prstGeom prst="roundRect">
-            <a:avLst/>
-          </a:prstGeom>
-          <a:solidFill>
-            <a:srgbClr val="C00000"/>
-          </a:solidFill>
-        </p:spPr>
-        <p:style>
-          <a:lnRef idx="2">
-            <a:schemeClr val="accent1">
-              <a:shade val="15000"/>
-            </a:schemeClr>
-          </a:lnRef>
-          <a:fillRef idx="1">
-            <a:schemeClr val="accent1"/>
-          </a:fillRef>
-          <a:effectRef idx="0">
-            <a:schemeClr val="accent1"/>
-          </a:effectRef>
-          <a:fontRef idx="minor">
-            <a:schemeClr val="lt1"/>
-          </a:fontRef>
-        </p:style>
-        <p:txBody>
-          <a:bodyPr rtlCol="0" anchor="ctr"/>
-          <a:lstStyle/>
-          <a:p>
-            <a:pPr algn="ctr"/>
-            <a:endParaRPr lang="en-US"/>
-          </a:p>
-        </p:txBody>
-      </p:sp>
-      <p:sp>
-        <p:nvSpPr>
           <p:cNvPr id="3" name="TextBox 2"/>
           <p:cNvSpPr txBox="1"/>
           <p:nvPr/>
@@ -4883,7 +4316,7 @@
 </p:sld>
 </file>
 
-<file path=ppt/slides/slide5.xml><?xml version="1.0" encoding="utf-8"?>
+<file path=ppt/slides/slide4.xml><?xml version="1.0" encoding="utf-8"?>
 <p:sld xmlns:a="http://schemas.openxmlformats.org/drawingml/2006/main" xmlns:r="http://schemas.openxmlformats.org/officeDocument/2006/relationships" xmlns:p="http://schemas.openxmlformats.org/presentationml/2006/main">
   <p:cSld>
     <p:spTree>
@@ -5233,7 +4666,7 @@
 </p:sld>
 </file>
 
-<file path=ppt/slides/slide6.xml><?xml version="1.0" encoding="utf-8"?>
+<file path=ppt/slides/slide5.xml><?xml version="1.0" encoding="utf-8"?>
 <p:sld xmlns:a="http://schemas.openxmlformats.org/drawingml/2006/main" xmlns:r="http://schemas.openxmlformats.org/officeDocument/2006/relationships" xmlns:p="http://schemas.openxmlformats.org/presentationml/2006/main">
   <p:cSld>
     <p:spTree>
@@ -5533,7 +4966,7 @@
 </p:sld>
 </file>
 
-<file path=ppt/slides/slide7.xml><?xml version="1.0" encoding="utf-8"?>
+<file path=ppt/slides/slide6.xml><?xml version="1.0" encoding="utf-8"?>
 <p:sld xmlns:a="http://schemas.openxmlformats.org/drawingml/2006/main" xmlns:r="http://schemas.openxmlformats.org/officeDocument/2006/relationships" xmlns:p="http://schemas.openxmlformats.org/presentationml/2006/main">
   <p:cSld>
     <p:spTree>
@@ -5671,6 +5104,354 @@
 </p:sld>
 </file>
 
+<file path=ppt/slides/slide7.xml><?xml version="1.0" encoding="utf-8"?>
+<p:sld xmlns:a="http://schemas.openxmlformats.org/drawingml/2006/main" xmlns:r="http://schemas.openxmlformats.org/officeDocument/2006/relationships" xmlns:p="http://schemas.openxmlformats.org/presentationml/2006/main">
+  <p:cSld>
+    <p:spTree>
+      <p:nvGrpSpPr>
+        <p:cNvPr id="1" name=""/>
+        <p:cNvGrpSpPr/>
+        <p:nvPr/>
+      </p:nvGrpSpPr>
+      <p:grpSpPr>
+        <a:xfrm>
+          <a:off x="0" y="0"/>
+          <a:ext cx="0" cy="0"/>
+          <a:chOff x="0" y="0"/>
+          <a:chExt cx="0" cy="0"/>
+        </a:xfrm>
+      </p:grpSpPr>
+      <p:sp>
+        <p:nvSpPr>
+          <p:cNvPr id="2" name="Rectangle: Rounded Corners 1"/>
+          <p:cNvSpPr/>
+          <p:nvPr/>
+        </p:nvSpPr>
+        <p:spPr>
+          <a:xfrm>
+            <a:off x="3736109" y="221673"/>
+            <a:ext cx="4719782" cy="517236"/>
+          </a:xfrm>
+          <a:prstGeom prst="roundRect">
+            <a:avLst/>
+          </a:prstGeom>
+          <a:solidFill>
+            <a:srgbClr val="C00000"/>
+          </a:solidFill>
+        </p:spPr>
+        <p:style>
+          <a:lnRef idx="2">
+            <a:schemeClr val="accent1">
+              <a:shade val="15000"/>
+            </a:schemeClr>
+          </a:lnRef>
+          <a:fillRef idx="1">
+            <a:schemeClr val="accent1"/>
+          </a:fillRef>
+          <a:effectRef idx="0">
+            <a:schemeClr val="accent1"/>
+          </a:effectRef>
+          <a:fontRef idx="minor">
+            <a:schemeClr val="lt1"/>
+          </a:fontRef>
+        </p:style>
+        <p:txBody>
+          <a:bodyPr rtlCol="0" anchor="ctr"/>
+          <a:lstStyle/>
+          <a:p>
+            <a:pPr algn="ctr"/>
+            <a:endParaRPr lang="en-US"/>
+          </a:p>
+        </p:txBody>
+      </p:sp>
+      <p:sp>
+        <p:nvSpPr>
+          <p:cNvPr id="3" name="TextBox 2"/>
+          <p:cNvSpPr txBox="1"/>
+          <p:nvPr/>
+        </p:nvSpPr>
+        <p:spPr>
+          <a:xfrm>
+            <a:off x="2660072" y="193965"/>
+            <a:ext cx="6871855" cy="584775"/>
+          </a:xfrm>
+          <a:prstGeom prst="rect">
+            <a:avLst/>
+          </a:prstGeom>
+          <a:noFill/>
+        </p:spPr>
+        <p:txBody>
+          <a:bodyPr wrap="square" rtlCol="0">
+            <a:spAutoFit/>
+          </a:bodyPr>
+          <a:lstStyle/>
+          <a:p>
+            <a:pPr algn="ctr"/>
+            <a:r>
+              <a:rPr lang="en-US" sz="3200" b="1" kern="0" dirty="0">
+                <a:solidFill>
+                  <a:schemeClr val="bg1"/>
+                </a:solidFill>
+                <a:effectLst/>
+                <a:ea typeface="Times New Roman" panose="02020603050405020304" pitchFamily="18" charset="0"/>
+              </a:rPr>
+              <a:t>Results</a:t>
+            </a:r>
+            <a:endParaRPr lang="en-US" sz="3200" b="1" dirty="0">
+              <a:solidFill>
+                <a:schemeClr val="bg1"/>
+              </a:solidFill>
+            </a:endParaRPr>
+          </a:p>
+        </p:txBody>
+      </p:sp>
+      <p:sp>
+        <p:nvSpPr>
+          <p:cNvPr id="5" name="TextBox 4">
+            <a:extLst>
+              <a:ext uri="{FF2B5EF4-FFF2-40B4-BE49-F238E27FC236}">
+                <a16:creationId xmlns:a16="http://schemas.microsoft.com/office/drawing/2014/main" id="{AD8FC542-D739-B040-9ADF-BB0CF3FCA97E}"/>
+              </a:ext>
+            </a:extLst>
+          </p:cNvPr>
+          <p:cNvSpPr txBox="1"/>
+          <p:nvPr/>
+        </p:nvSpPr>
+        <p:spPr>
+          <a:xfrm>
+            <a:off x="3181524" y="806448"/>
+            <a:ext cx="6094602" cy="5632311"/>
+          </a:xfrm>
+          <a:prstGeom prst="rect">
+            <a:avLst/>
+          </a:prstGeom>
+          <a:noFill/>
+        </p:spPr>
+        <p:txBody>
+          <a:bodyPr wrap="square">
+            <a:spAutoFit/>
+          </a:bodyPr>
+          <a:lstStyle/>
+          <a:p>
+            <a:pPr>
+              <a:lnSpc>
+                <a:spcPct val="150000"/>
+              </a:lnSpc>
+              <a:buNone/>
+            </a:pPr>
+            <a:r>
+              <a:rPr lang="en-IN" b="1" dirty="0"/>
+              <a:t>Expected Results</a:t>
+            </a:r>
+          </a:p>
+          <a:p>
+            <a:pPr>
+              <a:lnSpc>
+                <a:spcPct val="150000"/>
+              </a:lnSpc>
+              <a:buNone/>
+            </a:pPr>
+            <a:r>
+              <a:rPr lang="en-IN" dirty="0"/>
+              <a:t>The system displays:</a:t>
+            </a:r>
+          </a:p>
+          <a:p>
+            <a:pPr marL="342900" lvl="0" indent="-342900">
+              <a:lnSpc>
+                <a:spcPct val="150000"/>
+              </a:lnSpc>
+              <a:buFont typeface="Arial" panose="020B0604020202020204" pitchFamily="34" charset="0"/>
+              <a:buChar char="•"/>
+            </a:pPr>
+            <a:r>
+              <a:rPr lang="en-IN" dirty="0"/>
+              <a:t>Uploaded paper name </a:t>
+            </a:r>
+          </a:p>
+          <a:p>
+            <a:pPr marL="342900" lvl="0" indent="-342900">
+              <a:lnSpc>
+                <a:spcPct val="150000"/>
+              </a:lnSpc>
+              <a:buFont typeface="Arial" panose="020B0604020202020204" pitchFamily="34" charset="0"/>
+              <a:buChar char="•"/>
+            </a:pPr>
+            <a:r>
+              <a:rPr lang="en-IN" dirty="0"/>
+              <a:t>Number of words extracted </a:t>
+            </a:r>
+          </a:p>
+          <a:p>
+            <a:pPr marL="342900" lvl="0" indent="-342900">
+              <a:lnSpc>
+                <a:spcPct val="150000"/>
+              </a:lnSpc>
+              <a:buFont typeface="Arial" panose="020B0604020202020204" pitchFamily="34" charset="0"/>
+              <a:buChar char="•"/>
+            </a:pPr>
+            <a:r>
+              <a:rPr lang="en-IN" dirty="0"/>
+              <a:t>Number of reference papers </a:t>
+            </a:r>
+            <a:r>
+              <a:rPr lang="en-IN" dirty="0" err="1"/>
+              <a:t>analyzed</a:t>
+            </a:r>
+            <a:r>
+              <a:rPr lang="en-IN" dirty="0"/>
+              <a:t> </a:t>
+            </a:r>
+          </a:p>
+          <a:p>
+            <a:pPr marL="342900" lvl="0" indent="-342900">
+              <a:lnSpc>
+                <a:spcPct val="150000"/>
+              </a:lnSpc>
+              <a:buFont typeface="Arial" panose="020B0604020202020204" pitchFamily="34" charset="0"/>
+              <a:buChar char="•"/>
+            </a:pPr>
+            <a:r>
+              <a:rPr lang="en-IN" dirty="0"/>
+              <a:t>Matching reference papers </a:t>
+            </a:r>
+          </a:p>
+          <a:p>
+            <a:pPr marL="342900" lvl="0" indent="-342900">
+              <a:lnSpc>
+                <a:spcPct val="150000"/>
+              </a:lnSpc>
+              <a:buFont typeface="Arial" panose="020B0604020202020204" pitchFamily="34" charset="0"/>
+              <a:buChar char="•"/>
+            </a:pPr>
+            <a:r>
+              <a:rPr lang="en-IN" dirty="0"/>
+              <a:t>Number of matching K-grams </a:t>
+            </a:r>
+          </a:p>
+          <a:p>
+            <a:pPr marL="342900" lvl="0" indent="-342900">
+              <a:lnSpc>
+                <a:spcPct val="150000"/>
+              </a:lnSpc>
+              <a:buFont typeface="Arial" panose="020B0604020202020204" pitchFamily="34" charset="0"/>
+              <a:buChar char="•"/>
+            </a:pPr>
+            <a:r>
+              <a:rPr lang="en-IN" dirty="0"/>
+              <a:t>Similarity percentage </a:t>
+            </a:r>
+          </a:p>
+          <a:p>
+            <a:pPr marL="342900" lvl="0" indent="-342900">
+              <a:lnSpc>
+                <a:spcPct val="150000"/>
+              </a:lnSpc>
+              <a:buFont typeface="Arial" panose="020B0604020202020204" pitchFamily="34" charset="0"/>
+              <a:buChar char="•"/>
+            </a:pPr>
+            <a:r>
+              <a:rPr lang="en-IN" dirty="0"/>
+              <a:t>Ranked list of similar papers </a:t>
+            </a:r>
+          </a:p>
+          <a:p>
+            <a:pPr>
+              <a:lnSpc>
+                <a:spcPct val="150000"/>
+              </a:lnSpc>
+              <a:buNone/>
+            </a:pPr>
+            <a:r>
+              <a:rPr lang="en-IN" b="1" dirty="0"/>
+              <a:t>Example:</a:t>
+            </a:r>
+          </a:p>
+          <a:p>
+            <a:pPr marL="285750" indent="-285750">
+              <a:buFont typeface="Arial" panose="020B0604020202020204" pitchFamily="34" charset="0"/>
+              <a:buChar char="•"/>
+            </a:pPr>
+            <a:r>
+              <a:rPr lang="en-IN" b="1" dirty="0"/>
+              <a:t>Uploaded Paper:</a:t>
+            </a:r>
+            <a:r>
+              <a:rPr lang="en-IN" dirty="0"/>
+              <a:t> ResearchPaper.pdf</a:t>
+            </a:r>
+          </a:p>
+          <a:p>
+            <a:pPr marL="285750" indent="-285750">
+              <a:buFont typeface="Arial" panose="020B0604020202020204" pitchFamily="34" charset="0"/>
+              <a:buChar char="•"/>
+            </a:pPr>
+            <a:r>
+              <a:rPr lang="en-IN" b="1" dirty="0"/>
+              <a:t>Reference Papers:</a:t>
+            </a:r>
+            <a:r>
+              <a:rPr lang="en-IN" dirty="0"/>
+              <a:t> 100</a:t>
+            </a:r>
+          </a:p>
+          <a:p>
+            <a:pPr marL="285750" indent="-285750">
+              <a:buFont typeface="Arial" panose="020B0604020202020204" pitchFamily="34" charset="0"/>
+              <a:buChar char="•"/>
+            </a:pPr>
+            <a:r>
+              <a:rPr lang="en-IN" b="1" dirty="0"/>
+              <a:t>K-Gram Size:</a:t>
+            </a:r>
+            <a:r>
+              <a:rPr lang="en-IN" dirty="0"/>
+              <a:t> 8</a:t>
+            </a:r>
+          </a:p>
+          <a:p>
+            <a:pPr marL="285750" indent="-285750">
+              <a:buFont typeface="Arial" panose="020B0604020202020204" pitchFamily="34" charset="0"/>
+              <a:buChar char="•"/>
+            </a:pPr>
+            <a:r>
+              <a:rPr lang="en-IN" b="1" dirty="0"/>
+              <a:t>Algorithm:</a:t>
+            </a:r>
+            <a:r>
+              <a:rPr lang="en-IN" dirty="0"/>
+              <a:t> Rolling Hash + Rabin-Karp</a:t>
+            </a:r>
+          </a:p>
+          <a:p>
+            <a:pPr marL="285750" indent="-285750">
+              <a:buFont typeface="Arial" panose="020B0604020202020204" pitchFamily="34" charset="0"/>
+              <a:buChar char="•"/>
+            </a:pPr>
+            <a:r>
+              <a:rPr lang="en-IN" b="1" dirty="0"/>
+              <a:t>Similarity:</a:t>
+            </a:r>
+            <a:r>
+              <a:rPr lang="en-IN" dirty="0"/>
+              <a:t> 32.45%</a:t>
+            </a:r>
+          </a:p>
+        </p:txBody>
+      </p:sp>
+    </p:spTree>
+    <p:extLst>
+      <p:ext uri="{BB962C8B-B14F-4D97-AF65-F5344CB8AC3E}">
+        <p14:creationId xmlns:p14="http://schemas.microsoft.com/office/powerpoint/2010/main" val="106092222"/>
+      </p:ext>
+    </p:extLst>
+  </p:cSld>
+  <p:clrMapOvr>
+    <a:masterClrMapping/>
+  </p:clrMapOvr>
+</p:sld>
+</file>
+
 <file path=ppt/slides/slide8.xml><?xml version="1.0" encoding="utf-8"?>
 <p:sld xmlns:a="http://schemas.openxmlformats.org/drawingml/2006/main" xmlns:r="http://schemas.openxmlformats.org/officeDocument/2006/relationships" xmlns:p="http://schemas.openxmlformats.org/presentationml/2006/main">
   <p:cSld>
@@ -5696,8 +5477,8 @@
         </p:nvSpPr>
         <p:spPr>
           <a:xfrm>
-            <a:off x="3736109" y="221673"/>
-            <a:ext cx="4719782" cy="517236"/>
+            <a:off x="3654372" y="262038"/>
+            <a:ext cx="6419945" cy="603950"/>
           </a:xfrm>
           <a:prstGeom prst="roundRect">
             <a:avLst/>
@@ -5739,8 +5520,8 @@
         </p:nvSpPr>
         <p:spPr>
           <a:xfrm>
-            <a:off x="2660072" y="193965"/>
-            <a:ext cx="6871855" cy="584775"/>
+            <a:off x="3547840" y="302403"/>
+            <a:ext cx="6871855" cy="523220"/>
           </a:xfrm>
           <a:prstGeom prst="rect">
             <a:avLst/>
@@ -5755,16 +5536,16 @@
           <a:p>
             <a:pPr algn="ctr"/>
             <a:r>
-              <a:rPr lang="en-US" sz="3200" b="1" kern="0" dirty="0">
+              <a:rPr lang="en-US" sz="2800" b="1" kern="0" dirty="0">
                 <a:solidFill>
                   <a:schemeClr val="bg1"/>
                 </a:solidFill>
                 <a:effectLst/>
                 <a:ea typeface="Times New Roman" panose="02020603050405020304" pitchFamily="18" charset="0"/>
               </a:rPr>
-              <a:t>Results</a:t>
-            </a:r>
-            <a:endParaRPr lang="en-US" sz="3200" b="1" dirty="0">
+              <a:t>Hardware and Software requirements</a:t>
+            </a:r>
+            <a:endParaRPr lang="en-US" sz="2800" b="1" dirty="0">
               <a:solidFill>
                 <a:schemeClr val="bg1"/>
               </a:solidFill>
@@ -5777,7 +5558,7 @@
           <p:cNvPr id="5" name="TextBox 4">
             <a:extLst>
               <a:ext uri="{FF2B5EF4-FFF2-40B4-BE49-F238E27FC236}">
-                <a16:creationId xmlns:a16="http://schemas.microsoft.com/office/drawing/2014/main" id="{AD8FC542-D739-B040-9ADF-BB0CF3FCA97E}"/>
+                <a16:creationId xmlns:a16="http://schemas.microsoft.com/office/drawing/2014/main" id="{314F482A-447A-FF14-1437-90E2C8604CC8}"/>
               </a:ext>
             </a:extLst>
           </p:cNvPr>
@@ -5786,8 +5567,8 @@
         </p:nvSpPr>
         <p:spPr>
           <a:xfrm>
-            <a:off x="3181524" y="806448"/>
-            <a:ext cx="6094602" cy="5632311"/>
+            <a:off x="3047301" y="1307439"/>
+            <a:ext cx="6094602" cy="4524315"/>
           </a:xfrm>
           <a:prstGeom prst="rect">
             <a:avLst/>
@@ -5801,207 +5582,193 @@
           <a:lstStyle/>
           <a:p>
             <a:pPr>
-              <a:lnSpc>
-                <a:spcPct val="150000"/>
-              </a:lnSpc>
               <a:buNone/>
             </a:pPr>
             <a:r>
               <a:rPr lang="en-IN" b="1" dirty="0"/>
-              <a:t>Expected Results</a:t>
-            </a:r>
-          </a:p>
-          <a:p>
-            <a:pPr>
-              <a:lnSpc>
-                <a:spcPct val="150000"/>
-              </a:lnSpc>
-              <a:buNone/>
-            </a:pPr>
-            <a:r>
-              <a:rPr lang="en-IN" dirty="0"/>
-              <a:t>The system displays:</a:t>
+              <a:t>Hardware Requirements</a:t>
             </a:r>
           </a:p>
           <a:p>
             <a:pPr marL="342900" lvl="0" indent="-342900">
-              <a:lnSpc>
-                <a:spcPct val="150000"/>
-              </a:lnSpc>
               <a:buFont typeface="Arial" panose="020B0604020202020204" pitchFamily="34" charset="0"/>
               <a:buChar char="•"/>
             </a:pPr>
             <a:r>
               <a:rPr lang="en-IN" dirty="0"/>
-              <a:t>Uploaded paper name </a:t>
+              <a:t>Computer/Laptop </a:t>
             </a:r>
           </a:p>
           <a:p>
             <a:pPr marL="342900" lvl="0" indent="-342900">
-              <a:lnSpc>
-                <a:spcPct val="150000"/>
-              </a:lnSpc>
               <a:buFont typeface="Arial" panose="020B0604020202020204" pitchFamily="34" charset="0"/>
               <a:buChar char="•"/>
             </a:pPr>
             <a:r>
               <a:rPr lang="en-IN" dirty="0"/>
-              <a:t>Number of words extracted </a:t>
+              <a:t>Minimum 4 GB RAM </a:t>
             </a:r>
           </a:p>
           <a:p>
             <a:pPr marL="342900" lvl="0" indent="-342900">
-              <a:lnSpc>
-                <a:spcPct val="150000"/>
-              </a:lnSpc>
               <a:buFont typeface="Arial" panose="020B0604020202020204" pitchFamily="34" charset="0"/>
               <a:buChar char="•"/>
             </a:pPr>
             <a:r>
               <a:rPr lang="en-IN" dirty="0"/>
-              <a:t>Number of reference papers </a:t>
-            </a:r>
-            <a:r>
-              <a:rPr lang="en-IN" dirty="0" err="1"/>
-              <a:t>analyzed</a:t>
-            </a:r>
-            <a:r>
-              <a:rPr lang="en-IN" dirty="0"/>
-              <a:t> </a:t>
+              <a:t>Minimum 10 GB available storage </a:t>
             </a:r>
           </a:p>
           <a:p>
             <a:pPr marL="342900" lvl="0" indent="-342900">
-              <a:lnSpc>
-                <a:spcPct val="150000"/>
-              </a:lnSpc>
               <a:buFont typeface="Arial" panose="020B0604020202020204" pitchFamily="34" charset="0"/>
               <a:buChar char="•"/>
             </a:pPr>
             <a:r>
               <a:rPr lang="en-IN" dirty="0"/>
-              <a:t>Matching reference papers </a:t>
+              <a:t>Internet connection for development/deployment</a:t>
+            </a:r>
+          </a:p>
+          <a:p>
+            <a:pPr lvl="0"/>
+            <a:r>
+              <a:rPr lang="en-IN" dirty="0"/>
+              <a:t> </a:t>
+            </a:r>
+          </a:p>
+          <a:p>
+            <a:pPr>
+              <a:buNone/>
+            </a:pPr>
+            <a:r>
+              <a:rPr lang="en-IN" b="1" dirty="0"/>
+              <a:t>Software Requirements</a:t>
             </a:r>
           </a:p>
           <a:p>
             <a:pPr marL="342900" lvl="0" indent="-342900">
-              <a:lnSpc>
-                <a:spcPct val="150000"/>
-              </a:lnSpc>
               <a:buFont typeface="Arial" panose="020B0604020202020204" pitchFamily="34" charset="0"/>
               <a:buChar char="•"/>
             </a:pPr>
             <a:r>
-              <a:rPr lang="en-IN" dirty="0"/>
-              <a:t>Number of matching K-grams </a:t>
+              <a:rPr lang="en-IN" b="1" dirty="0"/>
+              <a:t>Operating System:</a:t>
+            </a:r>
+            <a:r>
+              <a:rPr lang="en-IN" dirty="0"/>
+              <a:t> Windows/Linux </a:t>
             </a:r>
           </a:p>
           <a:p>
             <a:pPr marL="342900" lvl="0" indent="-342900">
-              <a:lnSpc>
-                <a:spcPct val="150000"/>
-              </a:lnSpc>
               <a:buFont typeface="Arial" panose="020B0604020202020204" pitchFamily="34" charset="0"/>
               <a:buChar char="•"/>
             </a:pPr>
             <a:r>
-              <a:rPr lang="en-IN" dirty="0"/>
-              <a:t>Similarity percentage </a:t>
+              <a:rPr lang="en-IN" b="1" dirty="0"/>
+              <a:t>Frontend:</a:t>
+            </a:r>
+            <a:r>
+              <a:rPr lang="en-IN" dirty="0"/>
+              <a:t> React.js + Vite </a:t>
             </a:r>
           </a:p>
           <a:p>
             <a:pPr marL="342900" lvl="0" indent="-342900">
-              <a:lnSpc>
-                <a:spcPct val="150000"/>
-              </a:lnSpc>
               <a:buFont typeface="Arial" panose="020B0604020202020204" pitchFamily="34" charset="0"/>
               <a:buChar char="•"/>
             </a:pPr>
             <a:r>
-              <a:rPr lang="en-IN" dirty="0"/>
-              <a:t>Ranked list of similar papers </a:t>
-            </a:r>
-          </a:p>
-          <a:p>
-            <a:pPr>
-              <a:lnSpc>
-                <a:spcPct val="150000"/>
-              </a:lnSpc>
-              <a:buNone/>
-            </a:pPr>
-            <a:r>
               <a:rPr lang="en-IN" b="1" dirty="0"/>
-              <a:t>Example:</a:t>
-            </a:r>
-          </a:p>
-          <a:p>
-            <a:pPr marL="285750" indent="-285750">
+              <a:t>Backend:</a:t>
+            </a:r>
+            <a:r>
+              <a:rPr lang="en-IN" dirty="0"/>
+              <a:t> Node.js + Express.js </a:t>
+            </a:r>
+          </a:p>
+          <a:p>
+            <a:pPr marL="342900" lvl="0" indent="-342900">
               <a:buFont typeface="Arial" panose="020B0604020202020204" pitchFamily="34" charset="0"/>
               <a:buChar char="•"/>
             </a:pPr>
             <a:r>
               <a:rPr lang="en-IN" b="1" dirty="0"/>
-              <a:t>Uploaded Paper:</a:t>
-            </a:r>
-            <a:r>
-              <a:rPr lang="en-IN" dirty="0"/>
-              <a:t> ResearchPaper.pdf</a:t>
-            </a:r>
-          </a:p>
-          <a:p>
-            <a:pPr marL="285750" indent="-285750">
+              <a:t>Language:</a:t>
+            </a:r>
+            <a:r>
+              <a:rPr lang="en-IN" dirty="0"/>
+              <a:t> JavaScript </a:t>
+            </a:r>
+          </a:p>
+          <a:p>
+            <a:pPr marL="342900" lvl="0" indent="-342900">
               <a:buFont typeface="Arial" panose="020B0604020202020204" pitchFamily="34" charset="0"/>
               <a:buChar char="•"/>
             </a:pPr>
             <a:r>
               <a:rPr lang="en-IN" b="1" dirty="0"/>
-              <a:t>Reference Papers:</a:t>
-            </a:r>
-            <a:r>
-              <a:rPr lang="en-IN" dirty="0"/>
-              <a:t> 100</a:t>
-            </a:r>
-          </a:p>
-          <a:p>
-            <a:pPr marL="285750" indent="-285750">
+              <a:t>PDF Processing:</a:t>
+            </a:r>
+            <a:r>
+              <a:rPr lang="en-IN" dirty="0"/>
+              <a:t> pdf-parse </a:t>
+            </a:r>
+          </a:p>
+          <a:p>
+            <a:pPr marL="342900" lvl="0" indent="-342900">
               <a:buFont typeface="Arial" panose="020B0604020202020204" pitchFamily="34" charset="0"/>
               <a:buChar char="•"/>
             </a:pPr>
             <a:r>
               <a:rPr lang="en-IN" b="1" dirty="0"/>
-              <a:t>K-Gram Size:</a:t>
-            </a:r>
-            <a:r>
-              <a:rPr lang="en-IN" dirty="0"/>
-              <a:t> 8</a:t>
-            </a:r>
-          </a:p>
-          <a:p>
-            <a:pPr marL="285750" indent="-285750">
+              <a:t>File Upload:</a:t>
+            </a:r>
+            <a:r>
+              <a:rPr lang="en-IN" dirty="0"/>
+              <a:t> Multer </a:t>
+            </a:r>
+          </a:p>
+          <a:p>
+            <a:pPr marL="342900" lvl="0" indent="-342900">
               <a:buFont typeface="Arial" panose="020B0604020202020204" pitchFamily="34" charset="0"/>
               <a:buChar char="•"/>
             </a:pPr>
             <a:r>
               <a:rPr lang="en-IN" b="1" dirty="0"/>
-              <a:t>Algorithm:</a:t>
-            </a:r>
-            <a:r>
-              <a:rPr lang="en-IN" dirty="0"/>
-              <a:t> Rolling Hash + Rabin-Karp</a:t>
-            </a:r>
-          </a:p>
-          <a:p>
-            <a:pPr marL="285750" indent="-285750">
+              <a:t>Algorithms:</a:t>
+            </a:r>
+            <a:r>
+              <a:rPr lang="en-IN" dirty="0"/>
+              <a:t> Rolling Hash + Rabin-Karp </a:t>
+            </a:r>
+          </a:p>
+          <a:p>
+            <a:pPr marL="342900" lvl="0" indent="-342900">
               <a:buFont typeface="Arial" panose="020B0604020202020204" pitchFamily="34" charset="0"/>
               <a:buChar char="•"/>
             </a:pPr>
             <a:r>
               <a:rPr lang="en-IN" b="1" dirty="0"/>
-              <a:t>Similarity:</a:t>
-            </a:r>
-            <a:r>
-              <a:rPr lang="en-IN" dirty="0"/>
-              <a:t> 32.45%</a:t>
+              <a:t>Dataset:</a:t>
+            </a:r>
+            <a:r>
+              <a:rPr lang="en-IN" dirty="0"/>
+              <a:t> Research Paper PDFs </a:t>
+            </a:r>
+          </a:p>
+          <a:p>
+            <a:pPr marL="342900" lvl="0" indent="-342900">
+              <a:buFont typeface="Arial" panose="020B0604020202020204" pitchFamily="34" charset="0"/>
+              <a:buChar char="•"/>
+            </a:pPr>
+            <a:r>
+              <a:rPr lang="en-IN" b="1" dirty="0"/>
+              <a:t>Editor:</a:t>
+            </a:r>
+            <a:r>
+              <a:rPr lang="en-IN" dirty="0"/>
+              <a:t> Visual Studio Code </a:t>
             </a:r>
           </a:p>
         </p:txBody>
@@ -6009,7 +5776,7 @@
     </p:spTree>
     <p:extLst>
       <p:ext uri="{BB962C8B-B14F-4D97-AF65-F5344CB8AC3E}">
-        <p14:creationId xmlns:p14="http://schemas.microsoft.com/office/powerpoint/2010/main" val="106092222"/>
+        <p14:creationId xmlns:p14="http://schemas.microsoft.com/office/powerpoint/2010/main" val="2292750904"/>
       </p:ext>
     </p:extLst>
   </p:cSld>
@@ -6044,8 +5811,8 @@
         </p:nvSpPr>
         <p:spPr>
           <a:xfrm>
-            <a:off x="3654372" y="262038"/>
-            <a:ext cx="6419945" cy="603950"/>
+            <a:off x="3736109" y="221673"/>
+            <a:ext cx="4719782" cy="517236"/>
           </a:xfrm>
           <a:prstGeom prst="roundRect">
             <a:avLst/>
@@ -6087,8 +5854,8 @@
         </p:nvSpPr>
         <p:spPr>
           <a:xfrm>
-            <a:off x="3547840" y="302403"/>
-            <a:ext cx="6871855" cy="523220"/>
+            <a:off x="2660072" y="187903"/>
+            <a:ext cx="6871855" cy="584775"/>
           </a:xfrm>
           <a:prstGeom prst="rect">
             <a:avLst/>
@@ -6103,20 +5870,13 @@
           <a:p>
             <a:pPr algn="ctr"/>
             <a:r>
-              <a:rPr lang="en-US" sz="2800" b="1" kern="0" dirty="0">
+              <a:rPr lang="en-US" sz="3200" b="1" dirty="0">
                 <a:solidFill>
                   <a:schemeClr val="bg1"/>
                 </a:solidFill>
-                <a:effectLst/>
-                <a:ea typeface="Times New Roman" panose="02020603050405020304" pitchFamily="18" charset="0"/>
               </a:rPr>
-              <a:t>Hardware and Software requirements</a:t>
-            </a:r>
-            <a:endParaRPr lang="en-US" sz="2800" b="1" dirty="0">
-              <a:solidFill>
-                <a:schemeClr val="bg1"/>
-              </a:solidFill>
-            </a:endParaRPr>
+              <a:t>Conclusion</a:t>
+            </a:r>
           </a:p>
         </p:txBody>
       </p:sp>
@@ -6125,7 +5885,7 @@
           <p:cNvPr id="5" name="TextBox 4">
             <a:extLst>
               <a:ext uri="{FF2B5EF4-FFF2-40B4-BE49-F238E27FC236}">
-                <a16:creationId xmlns:a16="http://schemas.microsoft.com/office/drawing/2014/main" id="{314F482A-447A-FF14-1437-90E2C8604CC8}"/>
+                <a16:creationId xmlns:a16="http://schemas.microsoft.com/office/drawing/2014/main" id="{41F255AE-85F2-273B-E169-DCFDB4BA4D29}"/>
               </a:ext>
             </a:extLst>
           </p:cNvPr>
@@ -6134,8 +5894,8 @@
         </p:nvSpPr>
         <p:spPr>
           <a:xfrm>
-            <a:off x="3047301" y="1307439"/>
-            <a:ext cx="6094602" cy="4524315"/>
+            <a:off x="3048698" y="1282596"/>
+            <a:ext cx="6094602" cy="4619854"/>
           </a:xfrm>
           <a:prstGeom prst="rect">
             <a:avLst/>
@@ -6148,204 +5908,106 @@
           </a:bodyPr>
           <a:lstStyle/>
           <a:p>
-            <a:pPr>
-              <a:buNone/>
-            </a:pPr>
-            <a:r>
-              <a:rPr lang="en-IN" b="1" dirty="0"/>
-              <a:t>Hardware Requirements</a:t>
-            </a:r>
-          </a:p>
-          <a:p>
             <a:pPr marL="342900" lvl="0" indent="-342900">
+              <a:lnSpc>
+                <a:spcPct val="150000"/>
+              </a:lnSpc>
               <a:buFont typeface="Arial" panose="020B0604020202020204" pitchFamily="34" charset="0"/>
               <a:buChar char="•"/>
             </a:pPr>
             <a:r>
-              <a:rPr lang="en-IN" dirty="0"/>
-              <a:t>Computer/Laptop </a:t>
+              <a:rPr lang="en-IN" dirty="0" err="1"/>
+              <a:t>PaperCheck</a:t>
+            </a:r>
+            <a:r>
+              <a:rPr lang="en-IN" dirty="0"/>
+              <a:t> provides an automated approach for plagiarism detection. </a:t>
             </a:r>
           </a:p>
           <a:p>
             <a:pPr marL="342900" lvl="0" indent="-342900">
+              <a:lnSpc>
+                <a:spcPct val="150000"/>
+              </a:lnSpc>
               <a:buFont typeface="Arial" panose="020B0604020202020204" pitchFamily="34" charset="0"/>
               <a:buChar char="•"/>
             </a:pPr>
             <a:r>
               <a:rPr lang="en-IN" dirty="0"/>
-              <a:t>Minimum 4 GB RAM </a:t>
+              <a:t>The system processes research papers and compares their textual content. </a:t>
             </a:r>
           </a:p>
           <a:p>
             <a:pPr marL="342900" lvl="0" indent="-342900">
+              <a:lnSpc>
+                <a:spcPct val="150000"/>
+              </a:lnSpc>
               <a:buFont typeface="Arial" panose="020B0604020202020204" pitchFamily="34" charset="0"/>
               <a:buChar char="•"/>
             </a:pPr>
             <a:r>
-              <a:rPr lang="en-IN" dirty="0"/>
-              <a:t>Minimum 10 GB available storage </a:t>
+              <a:rPr lang="en-IN" b="1" dirty="0"/>
+              <a:t>Rolling Hash</a:t>
+            </a:r>
+            <a:r>
+              <a:rPr lang="en-IN" dirty="0"/>
+              <a:t> efficiently generates hash values for K-grams. </a:t>
             </a:r>
           </a:p>
           <a:p>
             <a:pPr marL="342900" lvl="0" indent="-342900">
+              <a:lnSpc>
+                <a:spcPct val="150000"/>
+              </a:lnSpc>
               <a:buFont typeface="Arial" panose="020B0604020202020204" pitchFamily="34" charset="0"/>
               <a:buChar char="•"/>
             </a:pPr>
             <a:r>
-              <a:rPr lang="en-IN" dirty="0"/>
-              <a:t>Internet connection for development/deployment</a:t>
-            </a:r>
-          </a:p>
-          <a:p>
-            <a:pPr lvl="0"/>
-            <a:r>
-              <a:rPr lang="en-IN" dirty="0"/>
-              <a:t> </a:t>
-            </a:r>
-          </a:p>
-          <a:p>
-            <a:pPr>
-              <a:buNone/>
-            </a:pPr>
-            <a:r>
               <a:rPr lang="en-IN" b="1" dirty="0"/>
-              <a:t>Software Requirements</a:t>
+              <a:t>Rabin-Karp</a:t>
+            </a:r>
+            <a:r>
+              <a:rPr lang="en-IN" dirty="0"/>
+              <a:t> identifies matching sequences using these hash values. </a:t>
             </a:r>
           </a:p>
           <a:p>
             <a:pPr marL="342900" lvl="0" indent="-342900">
+              <a:lnSpc>
+                <a:spcPct val="150000"/>
+              </a:lnSpc>
               <a:buFont typeface="Arial" panose="020B0604020202020204" pitchFamily="34" charset="0"/>
               <a:buChar char="•"/>
             </a:pPr>
             <a:r>
-              <a:rPr lang="en-IN" b="1" dirty="0"/>
-              <a:t>Operating System:</a:t>
-            </a:r>
-            <a:r>
-              <a:rPr lang="en-IN" dirty="0"/>
-              <a:t> Windows/Linux </a:t>
+              <a:rPr lang="en-IN" dirty="0"/>
+              <a:t>The system generates similarity percentages and ranked matching papers. </a:t>
             </a:r>
           </a:p>
           <a:p>
             <a:pPr marL="342900" lvl="0" indent="-342900">
+              <a:lnSpc>
+                <a:spcPct val="150000"/>
+              </a:lnSpc>
               <a:buFont typeface="Arial" panose="020B0604020202020204" pitchFamily="34" charset="0"/>
               <a:buChar char="•"/>
             </a:pPr>
             <a:r>
+              <a:rPr lang="en-IN" dirty="0"/>
+              <a:t>The project demonstrates how </a:t>
+            </a:r>
+            <a:r>
               <a:rPr lang="en-IN" b="1" dirty="0"/>
-              <a:t>Frontend:</a:t>
-            </a:r>
-            <a:r>
-              <a:rPr lang="en-IN" dirty="0"/>
-              <a:t> React.js + Vite </a:t>
-            </a:r>
-          </a:p>
-          <a:p>
-            <a:pPr marL="342900" lvl="0" indent="-342900">
-              <a:buFont typeface="Arial" panose="020B0604020202020204" pitchFamily="34" charset="0"/>
-              <a:buChar char="•"/>
-            </a:pPr>
-            <a:r>
-              <a:rPr lang="en-IN" b="1" dirty="0"/>
-              <a:t>Backend:</a:t>
-            </a:r>
-            <a:r>
-              <a:rPr lang="en-IN" dirty="0"/>
-              <a:t> Node.js + Express.js </a:t>
-            </a:r>
-          </a:p>
-          <a:p>
-            <a:pPr marL="342900" lvl="0" indent="-342900">
-              <a:buFont typeface="Arial" panose="020B0604020202020204" pitchFamily="34" charset="0"/>
-              <a:buChar char="•"/>
-            </a:pPr>
-            <a:r>
-              <a:rPr lang="en-IN" b="1" dirty="0"/>
-              <a:t>Language:</a:t>
-            </a:r>
-            <a:r>
-              <a:rPr lang="en-IN" dirty="0"/>
-              <a:t> JavaScript </a:t>
-            </a:r>
-          </a:p>
-          <a:p>
-            <a:pPr marL="342900" lvl="0" indent="-342900">
-              <a:buFont typeface="Arial" panose="020B0604020202020204" pitchFamily="34" charset="0"/>
-              <a:buChar char="•"/>
-            </a:pPr>
-            <a:r>
-              <a:rPr lang="en-IN" b="1" dirty="0"/>
-              <a:t>PDF Processing:</a:t>
-            </a:r>
-            <a:r>
-              <a:rPr lang="en-IN" dirty="0"/>
-              <a:t> pdf-parse </a:t>
-            </a:r>
-          </a:p>
-          <a:p>
-            <a:pPr marL="342900" lvl="0" indent="-342900">
-              <a:buFont typeface="Arial" panose="020B0604020202020204" pitchFamily="34" charset="0"/>
-              <a:buChar char="•"/>
-            </a:pPr>
-            <a:r>
-              <a:rPr lang="en-IN" b="1" dirty="0"/>
-              <a:t>File Upload:</a:t>
-            </a:r>
-            <a:r>
-              <a:rPr lang="en-IN" dirty="0"/>
-              <a:t> Multer </a:t>
-            </a:r>
-          </a:p>
-          <a:p>
-            <a:pPr marL="342900" lvl="0" indent="-342900">
-              <a:buFont typeface="Arial" panose="020B0604020202020204" pitchFamily="34" charset="0"/>
-              <a:buChar char="•"/>
-            </a:pPr>
-            <a:r>
-              <a:rPr lang="en-IN" b="1" dirty="0"/>
-              <a:t>Algorithms:</a:t>
-            </a:r>
-            <a:r>
-              <a:rPr lang="en-IN" dirty="0"/>
-              <a:t> Rolling Hash + Rabin-Karp </a:t>
-            </a:r>
-          </a:p>
-          <a:p>
-            <a:pPr marL="342900" lvl="0" indent="-342900">
-              <a:buFont typeface="Arial" panose="020B0604020202020204" pitchFamily="34" charset="0"/>
-              <a:buChar char="•"/>
-            </a:pPr>
-            <a:r>
-              <a:rPr lang="en-IN" b="1" dirty="0"/>
-              <a:t>Dataset:</a:t>
-            </a:r>
-            <a:r>
-              <a:rPr lang="en-IN" dirty="0"/>
-              <a:t> Research Paper PDFs </a:t>
-            </a:r>
-          </a:p>
-          <a:p>
-            <a:pPr marL="342900" lvl="0" indent="-342900">
-              <a:buFont typeface="Arial" panose="020B0604020202020204" pitchFamily="34" charset="0"/>
-              <a:buChar char="•"/>
-            </a:pPr>
-            <a:r>
-              <a:rPr lang="en-IN" b="1" dirty="0"/>
-              <a:t>Editor:</a:t>
-            </a:r>
-            <a:r>
-              <a:rPr lang="en-IN" dirty="0"/>
-              <a:t> Visual Studio Code </a:t>
+              <a:t>DSA concepts can be applied to a real-world problem</a:t>
+            </a:r>
+            <a:r>
+              <a:rPr lang="en-IN" dirty="0"/>
+              <a:t>.</a:t>
             </a:r>
           </a:p>
         </p:txBody>
       </p:sp>
     </p:spTree>
-    <p:extLst>
-      <p:ext uri="{BB962C8B-B14F-4D97-AF65-F5344CB8AC3E}">
-        <p14:creationId xmlns:p14="http://schemas.microsoft.com/office/powerpoint/2010/main" val="2292750904"/>
-      </p:ext>
-    </p:extLst>
   </p:cSld>
   <p:clrMapOvr>
     <a:masterClrMapping/>

</xml_diff>